<commit_message>
branding: prominently integrate BookMyCollege across PowerPoint deck and viva guides
</commit_message>
<xml_diff>
--- a/CAMPUS_EVENT_PLATFORM_PRESENTATION.pptx
+++ b/CAMPUS_EVENT_PLATFORM_PRESENTATION.pptx
@@ -3150,8 +3150,8 @@
         </p:nvSpPr>
         <p:spPr>
           <a:xfrm>
-            <a:off x="914400" y="1645920"/>
-            <a:ext cx="10332720" cy="2011680"/>
+            <a:off x="914400" y="1554480"/>
+            <a:ext cx="10332720" cy="2194560"/>
           </a:xfrm>
           <a:prstGeom prst="rect">
             <a:avLst/>
@@ -3166,7 +3166,7 @@
           <a:p>
             <a:pPr>
               <a:spcAft>
-                <a:spcPts val="1200"/>
+                <a:spcPts val="1000"/>
               </a:spcAft>
               <a:defRPr sz="1100" b="1">
                 <a:solidFill>
@@ -3181,16 +3181,16 @@
           <a:p>
             <a:pPr>
               <a:spcAft>
-                <a:spcPts val="1200"/>
-              </a:spcAft>
-              <a:defRPr sz="3400" b="1">
+                <a:spcPts val="800"/>
+              </a:spcAft>
+              <a:defRPr sz="4000" b="1">
                 <a:solidFill>
                   <a:srgbClr val="0F172A"/>
                 </a:solidFill>
               </a:defRPr>
             </a:pPr>
             <a:r>
-              <a:t>Campus Event &amp; Crowdfunding Platform</a:t>
+              <a:t>BookMyCollege</a:t>
             </a:r>
           </a:p>
           <a:p>
@@ -3202,11 +3202,7 @@
               </a:defRPr>
             </a:pPr>
             <a:r>
-              <a:t>An all-in-one web portal featuring atomic seat booking, zero double-booking,</a:t>
-            </a:r>
-            <a:br/>
-            <a:r>
-              <a:t>in-browser QR scanning, verified certificates &amp; festival crowdfunding.</a:t>
+              <a:t>All-in-One Campus Event Ticketing, Real-Time Crowdfunding &amp; In-Browser QR Pass Platform</a:t>
             </a:r>
           </a:p>
         </p:txBody>
@@ -3220,7 +3216,7 @@
         <p:spPr>
           <a:xfrm>
             <a:off x="914400" y="4297680"/>
-            <a:ext cx="10362895" cy="1463040"/>
+            <a:ext cx="10362895" cy="1554480"/>
           </a:xfrm>
           <a:prstGeom prst="roundRect">
             <a:avLst/>
@@ -3263,7 +3259,7 @@
               </a:defRPr>
             </a:pPr>
             <a:r>
-              <a:t>Technology Stack &amp; Core Specifications</a:t>
+              <a:t>BookMyCollege Core Architecture &amp; Highlights</a:t>
             </a:r>
           </a:p>
           <a:p>
@@ -3275,15 +3271,15 @@
               </a:defRPr>
             </a:pPr>
             <a:r>
-              <a:t>Frontend: HTML5, Tailwind CSS, Vanilla JavaScript (Single Page Architecture, Mobile Responsive)</a:t>
+              <a:t>• Frontend: HTML5, Tailwind CSS, Vanilla JavaScript (Single Page Architecture, 100% Mobile Responsive)</a:t>
             </a:r>
             <a:br/>
             <a:r>
-              <a:t>Database &amp; Auth: Supabase (PostgreSQL 15), ACID Row-Level Security | Payments: Razorpay Serverless Node.js APIs</a:t>
+              <a:t>• Cloud Backend: Supabase (PostgreSQL 15), ACID Row-Level Locking | Payments: Razorpay Serverless API</a:t>
             </a:r>
             <a:br/>
             <a:r>
-              <a:t>Hardware Integration: WebRTC Camera Barcode Scanning | Graphics: Client-Side HTML5 Canvas Vector Engine</a:t>
+              <a:t>• Innovations: Zero Double-Booking, Instant Auto-Refunds, In-Browser Camera Scanner &amp; Locked Canvas Certificates</a:t>
             </a:r>
           </a:p>
         </p:txBody>
@@ -3336,7 +3332,7 @@
               </a:defRPr>
             </a:pPr>
             <a:r>
-              <a:t>CAMPUS EVENT &amp; CROWDFUNDING PLATFORM</a:t>
+              <a:t>BOOKMYCOLLEGE • CAMPUS EVENT &amp; CROWDFUNDING PLATFORM</a:t>
             </a:r>
           </a:p>
         </p:txBody>
@@ -3677,7 +3673,7 @@
               </a:defRPr>
             </a:pPr>
             <a:r>
-              <a:t>• Our web scanner runs instantly on mobile Chrome/Safari with zero installation.</a:t>
+              <a:t>• BookMyCollege scanner runs instantly on mobile Chrome/Safari with zero installation.</a:t>
             </a:r>
           </a:p>
         </p:txBody>
@@ -3817,7 +3813,7 @@
               </a:defRPr>
             </a:pPr>
             <a:r>
-              <a:t>CAMPUS EVENT &amp; CROWDFUNDING PLATFORM</a:t>
+              <a:t>BOOKMYCOLLEGE • CAMPUS EVENT &amp; CROWDFUNDING PLATFORM</a:t>
             </a:r>
           </a:p>
         </p:txBody>
@@ -4212,14 +4208,14 @@
               <a:spcAft>
                 <a:spcPts val="1200"/>
               </a:spcAft>
-              <a:defRPr sz="2800" b="1">
+              <a:defRPr sz="3600" b="1">
                 <a:solidFill>
                   <a:srgbClr val="0F172A"/>
                 </a:solidFill>
               </a:defRPr>
             </a:pPr>
             <a:r>
-              <a:t>Campus Event &amp; Crowdfunding Platform</a:t>
+              <a:t>BookMyCollege</a:t>
             </a:r>
           </a:p>
           <a:p>
@@ -4299,7 +4295,7 @@
               </a:defRPr>
             </a:pPr>
             <a:r>
-              <a:t>CAMPUS EVENT &amp; CROWDFUNDING PLATFORM</a:t>
+              <a:t>BOOKMYCOLLEGE • CAMPUS EVENT &amp; CROWDFUNDING PLATFORM</a:t>
             </a:r>
           </a:p>
         </p:txBody>
@@ -4391,7 +4387,7 @@
               </a:defRPr>
             </a:pPr>
             <a:r>
-              <a:t>1. Messy Google Forms &amp; WhatsApp</a:t>
+              <a:t>1. Messy Forms &amp; WhatsApp</a:t>
             </a:r>
           </a:p>
           <a:p>
@@ -4523,7 +4519,7 @@
               </a:defRPr>
             </a:pPr>
             <a:r>
-              <a:t>• No reliable check-in at the auditorium door.</a:t>
+              <a:t>• No reliable check-in system at the auditorium door.</a:t>
             </a:r>
           </a:p>
           <a:p>
@@ -4625,7 +4621,7 @@
               </a:defRPr>
             </a:pPr>
             <a:r>
-              <a:t>3. Fragmented Festival Fundraising</a:t>
+              <a:t>3. Fragmented Fest Fundraising</a:t>
             </a:r>
           </a:p>
           <a:p>
@@ -4723,7 +4719,7 @@
               </a:defRPr>
             </a:pPr>
             <a:r>
-              <a:t>CAMPUS EVENT &amp; CROWDFUNDING PLATFORM</a:t>
+              <a:t>BOOKMYCOLLEGE • CAMPUS EVENT &amp; CROWDFUNDING PLATFORM</a:t>
             </a:r>
           </a:p>
         </p:txBody>
@@ -4758,7 +4754,7 @@
               </a:defRPr>
             </a:pPr>
             <a:r>
-              <a:t>Our Solution: A Unified Campus Event Operating System</a:t>
+              <a:t>The Solution: BookMyCollege Unified Campus OS</a:t>
             </a:r>
           </a:p>
         </p:txBody>
@@ -5219,7 +5215,7 @@
               </a:defRPr>
             </a:pPr>
             <a:r>
-              <a:t>CAMPUS EVENT &amp; CROWDFUNDING PLATFORM</a:t>
+              <a:t>BOOKMYCOLLEGE • CAMPUS EVENT &amp; CROWDFUNDING PLATFORM</a:t>
             </a:r>
           </a:p>
         </p:txBody>
@@ -5254,7 +5250,7 @@
               </a:defRPr>
             </a:pPr>
             <a:r>
-              <a:t>System Architecture: Decoupled &amp; Serverless Stack</a:t>
+              <a:t>BookMyCollege Architecture &amp; Technology Stack</a:t>
             </a:r>
           </a:p>
         </p:txBody>
@@ -5955,7 +5951,7 @@
               </a:defRPr>
             </a:pPr>
             <a:r>
-              <a:t>CAMPUS EVENT &amp; CROWDFUNDING PLATFORM</a:t>
+              <a:t>BOOKMYCOLLEGE • CAMPUS EVENT &amp; CROWDFUNDING PLATFORM</a:t>
             </a:r>
           </a:p>
         </p:txBody>
@@ -5990,7 +5986,7 @@
               </a:defRPr>
             </a:pPr>
             <a:r>
-              <a:t>Deep Dive: Concurrency, Seat Locking &amp; Auto-Refunds</a:t>
+              <a:t>Concurrency: How BookMyCollege Prevents Double-Booking</a:t>
             </a:r>
           </a:p>
         </p:txBody>
@@ -6442,7 +6438,7 @@
               </a:defRPr>
             </a:pPr>
             <a:r>
-              <a:t>CAMPUS EVENT &amp; CROWDFUNDING PLATFORM</a:t>
+              <a:t>BOOKMYCOLLEGE • CAMPUS EVENT &amp; CROWDFUNDING PLATFORM</a:t>
             </a:r>
           </a:p>
         </p:txBody>
@@ -6477,7 +6473,7 @@
               </a:defRPr>
             </a:pPr>
             <a:r>
-              <a:t>Deep Dive: Zero-Trust QR Check-In &amp; Gatekeeper Scanner</a:t>
+              <a:t>Gatekeeper Scanner: In-Browser Verification &amp; Anti-Fraud</a:t>
             </a:r>
           </a:p>
         </p:txBody>
@@ -6594,7 +6590,7 @@
               </a:defRPr>
             </a:pPr>
             <a:r>
-              <a:t>• Our Cryptographic Architecture:</a:t>
+              <a:t>• BookMyCollege Cryptographic Architecture:</a:t>
             </a:r>
           </a:p>
           <a:p>
@@ -6929,7 +6925,7 @@
               </a:defRPr>
             </a:pPr>
             <a:r>
-              <a:t>CAMPUS EVENT &amp; CROWDFUNDING PLATFORM</a:t>
+              <a:t>BOOKMYCOLLEGE • CAMPUS EVENT &amp; CROWDFUNDING PLATFORM</a:t>
             </a:r>
           </a:p>
         </p:txBody>
@@ -6964,7 +6960,7 @@
               </a:defRPr>
             </a:pPr>
             <a:r>
-              <a:t>Deep Dive: Verified Certificates &amp; Crowdfunding</a:t>
+              <a:t>Verified Certificates &amp; Festival Crowdfunding</a:t>
             </a:r>
           </a:p>
         </p:txBody>
@@ -7506,7 +7502,7 @@
               </a:defRPr>
             </a:pPr>
             <a:r>
-              <a:t>CAMPUS EVENT &amp; CROWDFUNDING PLATFORM</a:t>
+              <a:t>BOOKMYCOLLEGE • CAMPUS EVENT &amp; CROWDFUNDING PLATFORM</a:t>
             </a:r>
           </a:p>
         </p:txBody>
@@ -7960,7 +7956,7 @@
               </a:defRPr>
             </a:pPr>
             <a:r>
-              <a:t>CAMPUS EVENT &amp; CROWDFUNDING PLATFORM</a:t>
+              <a:t>BOOKMYCOLLEGE • CAMPUS EVENT &amp; CROWDFUNDING PLATFORM</a:t>
             </a:r>
           </a:p>
         </p:txBody>
@@ -7995,7 +7991,7 @@
               </a:defRPr>
             </a:pPr>
             <a:r>
-              <a:t>Step-by-Step Live Demonstration Walkthrough</a:t>
+              <a:t>BookMyCollege Live Demonstration Flow</a:t>
             </a:r>
           </a:p>
         </p:txBody>
@@ -8067,7 +8063,7 @@
               </a:defRPr>
             </a:pPr>
             <a:r>
-              <a:t>• Open Home Portal.</a:t>
+              <a:t>• Open BookMyCollege.</a:t>
             </a:r>
           </a:p>
           <a:p>

</xml_diff>